<commit_message>
atualização da apresentação 1
</commit_message>
<xml_diff>
--- a/001_apresentacao_dia1.pptx
+++ b/001_apresentacao_dia1.pptx
@@ -136,7 +136,7 @@
 <file path=ppt/revisionInfo.xml><?xml version="1.0" encoding="utf-8"?>
 <p1510:revInfo xmlns:a="http://schemas.openxmlformats.org/drawingml/2006/main" xmlns:r="http://schemas.openxmlformats.org/officeDocument/2006/relationships" xmlns:p1510="http://schemas.microsoft.com/office/powerpoint/2015/10/main">
   <p1510:revLst>
-    <p1510:client id="{544D3FB3-DA0C-4685-B5B7-DF7A9F8CCA31}" v="2" dt="2026-05-22T22:17:40.143"/>
+    <p1510:client id="{544D3FB3-DA0C-4685-B5B7-DF7A9F8CCA31}" v="4" dt="2026-05-22T22:36:42.662"/>
   </p1510:revLst>
 </p1510:revInfo>
 </file>
@@ -170,7 +170,7 @@
   <pc:docChgLst>
     <pc:chgData name="Felipe Pfrimer" userId="0b8eec0ce5f0414b" providerId="LiveId" clId="{99A03BAB-098E-4974-8324-154A37D5CA80}"/>
     <pc:docChg chg="undo custSel modSld">
-      <pc:chgData name="Felipe Pfrimer" userId="0b8eec0ce5f0414b" providerId="LiveId" clId="{99A03BAB-098E-4974-8324-154A37D5CA80}" dt="2026-05-22T22:19:40.195" v="52" actId="20577"/>
+      <pc:chgData name="Felipe Pfrimer" userId="0b8eec0ce5f0414b" providerId="LiveId" clId="{99A03BAB-098E-4974-8324-154A37D5CA80}" dt="2026-05-22T22:37:05.382" v="75" actId="20577"/>
       <pc:docMkLst>
         <pc:docMk/>
       </pc:docMkLst>
@@ -254,6 +254,36 @@
             <pc:docMk/>
             <pc:sldMk cId="4167250517" sldId="271"/>
             <ac:spMk id="3" creationId="{7F921542-294F-DC49-44F1-0204CE704CC5}"/>
+          </ac:spMkLst>
+        </pc:spChg>
+      </pc:sldChg>
+      <pc:sldChg chg="modSp mod">
+        <pc:chgData name="Felipe Pfrimer" userId="0b8eec0ce5f0414b" providerId="LiveId" clId="{99A03BAB-098E-4974-8324-154A37D5CA80}" dt="2026-05-22T22:36:57.183" v="74" actId="207"/>
+        <pc:sldMkLst>
+          <pc:docMk/>
+          <pc:sldMk cId="873981961" sldId="276"/>
+        </pc:sldMkLst>
+        <pc:spChg chg="mod">
+          <ac:chgData name="Felipe Pfrimer" userId="0b8eec0ce5f0414b" providerId="LiveId" clId="{99A03BAB-098E-4974-8324-154A37D5CA80}" dt="2026-05-22T22:36:57.183" v="74" actId="207"/>
+          <ac:spMkLst>
+            <pc:docMk/>
+            <pc:sldMk cId="873981961" sldId="276"/>
+            <ac:spMk id="2" creationId="{E58941B7-8D8F-3C6D-E0C3-C4D593EDB3DE}"/>
+          </ac:spMkLst>
+        </pc:spChg>
+      </pc:sldChg>
+      <pc:sldChg chg="modSp mod">
+        <pc:chgData name="Felipe Pfrimer" userId="0b8eec0ce5f0414b" providerId="LiveId" clId="{99A03BAB-098E-4974-8324-154A37D5CA80}" dt="2026-05-22T22:37:05.382" v="75" actId="20577"/>
+        <pc:sldMkLst>
+          <pc:docMk/>
+          <pc:sldMk cId="2521361056" sldId="277"/>
+        </pc:sldMkLst>
+        <pc:spChg chg="mod">
+          <ac:chgData name="Felipe Pfrimer" userId="0b8eec0ce5f0414b" providerId="LiveId" clId="{99A03BAB-098E-4974-8324-154A37D5CA80}" dt="2026-05-22T22:37:05.382" v="75" actId="20577"/>
+          <ac:spMkLst>
+            <pc:docMk/>
+            <pc:sldMk cId="2521361056" sldId="277"/>
+            <ac:spMk id="3" creationId="{0A4886ED-BC5E-02E9-3D16-D9DABD0905B5}"/>
           </ac:spMkLst>
         </pc:spChg>
       </pc:sldChg>
@@ -5586,13 +5616,54 @@
         </p:nvSpPr>
         <p:spPr/>
         <p:txBody>
-          <a:bodyPr/>
+          <a:bodyPr>
+            <a:normAutofit fontScale="90000"/>
+          </a:bodyPr>
           <a:lstStyle/>
           <a:p>
             <a:r>
               <a:rPr lang="pt-BR" dirty="0"/>
               <a:t>Comandos básicos de terminal</a:t>
             </a:r>
+            <a:br>
+              <a:rPr lang="pt-BR" dirty="0"/>
+            </a:br>
+            <a:r>
+              <a:rPr lang="pt-BR" sz="3100" dirty="0">
+                <a:solidFill>
+                  <a:srgbClr val="FFFF00"/>
+                </a:solidFill>
+              </a:rPr>
+              <a:t>github.com/</a:t>
+            </a:r>
+            <a:r>
+              <a:rPr lang="pt-BR" sz="3100" dirty="0" err="1">
+                <a:solidFill>
+                  <a:srgbClr val="FFFF00"/>
+                </a:solidFill>
+              </a:rPr>
+              <a:t>fpfrimer</a:t>
+            </a:r>
+            <a:r>
+              <a:rPr lang="pt-BR" sz="3100" dirty="0">
+                <a:solidFill>
+                  <a:srgbClr val="FFFF00"/>
+                </a:solidFill>
+              </a:rPr>
+              <a:t>/</a:t>
+            </a:r>
+            <a:r>
+              <a:rPr lang="pt-BR" sz="3100" dirty="0" err="1">
+                <a:solidFill>
+                  <a:srgbClr val="FFFF00"/>
+                </a:solidFill>
+              </a:rPr>
+              <a:t>aulas_metrologia_por_imagem</a:t>
+            </a:r>
+            <a:br>
+              <a:rPr lang="pt-BR" sz="3100" dirty="0"/>
+            </a:br>
+            <a:endParaRPr lang="pt-BR" dirty="0"/>
           </a:p>
         </p:txBody>
       </p:sp>
@@ -5719,27 +5790,18 @@
           <a:p>
             <a:r>
               <a:rPr lang="pt-BR" dirty="0"/>
-              <a:t>Scripts básicos de </a:t>
-            </a:r>
-            <a:r>
-              <a:rPr lang="pt-BR" dirty="0" err="1"/>
-              <a:t>python</a:t>
-            </a:r>
-            <a:endParaRPr lang="pt-BR" dirty="0"/>
-          </a:p>
-          <a:p>
-            <a:r>
-              <a:rPr lang="pt-BR"/>
-              <a:t>Automação simples </a:t>
-            </a:r>
-            <a:r>
-              <a:rPr lang="pt-BR" dirty="0"/>
-              <a:t>com o </a:t>
+              <a:t>Automação simples com o </a:t>
             </a:r>
             <a:r>
               <a:rPr lang="pt-BR" dirty="0" err="1"/>
               <a:t>systemd</a:t>
             </a:r>
+            <a:endParaRPr lang="pt-BR" dirty="0"/>
+          </a:p>
+          <a:p>
+            <a:endParaRPr lang="pt-BR" dirty="0"/>
+          </a:p>
+          <a:p>
             <a:endParaRPr lang="pt-BR" dirty="0"/>
           </a:p>
         </p:txBody>

</xml_diff>